<commit_message>
Growth report: refresh 15O weekly series through wk202633
Co-Authored-By: Claude Fable 5.1 <noreply@anthropic.com>
</commit_message>
<xml_diff>
--- a/Growth Report/Catalyst_Growth_Report.pptx
+++ b/Growth Report/Catalyst_Growth_Report.pptx
@@ -3198,7 +3198,7 @@
                 </a:solidFill>
                 <a:latin typeface="Futura"/>
               </a:rPr>
-              <a:t>Generated July 31, 2026</a:t>
+              <a:t>Generated September 22, 2026</a:t>
             </a:r>
           </a:p>
         </p:txBody>
@@ -3531,7 +3531,7 @@
         <p:spPr>
           <a:xfrm>
             <a:off x="6263640" y="1691640"/>
-            <a:ext cx="6298163" cy="4114800"/>
+            <a:ext cx="6304597" cy="4114800"/>
           </a:xfrm>
           <a:prstGeom prst="rect">
             <a:avLst/>
@@ -3568,7 +3568,7 @@
                 </a:solidFill>
                 <a:latin typeface="Futura"/>
               </a:rPr>
-              <a:t>Linear weekly growth:  +202 units/week   •   +0.056 U/S/W per week   (Wk 1: 835 u / 0.238  →  Wk 25: 7,585 u / 2.107)</a:t>
+              <a:t>Linear weekly growth:  +256 units/week   •   +0.070 U/S/W per week   (Wk 1: 835 u / 0.238  →  Wk 33: 10,382 u / 2.878)</a:t>
             </a:r>
           </a:p>
         </p:txBody>

</xml_diff>